<commit_message>
Added concise slide text for data split and target distribution graphs
- Added professional, compact text to accompany the two graphs in the presentation.
- The text explains the sample counts in each data subset (x_train, x_test, y_train, y_test) and verifies the 80/20 split.
- Also includes an explanation for the recovery status distribution graph, ensuring target distribution consistency.
- Provides machine analysis insights to underline the importance of a balanced and reliable model training process.
</commit_message>
<xml_diff>
--- a/Assignment 1.pptx
+++ b/Assignment 1.pptx
@@ -11,7 +11,8 @@
     <p:sldId id="259" r:id="rId5"/>
     <p:sldId id="260" r:id="rId6"/>
     <p:sldId id="261" r:id="rId7"/>
-    <p:sldId id="262" r:id="rId8"/>
+    <p:sldId id="263" r:id="rId8"/>
+    <p:sldId id="264" r:id="rId9"/>
   </p:sldIdLst>
   <p:sldSz cx="12192000" cy="6858000"/>
   <p:notesSz cx="6858000" cy="9144000"/>
@@ -257,7 +258,7 @@
           <a:p>
             <a:fld id="{D01D6C5B-8995-4CBE-A6C8-F37ABE6A0A7A}" type="datetimeFigureOut">
               <a:rPr lang="en-US" smtClean="0"/>
-              <a:t>3/6/2025</a:t>
+              <a:t>3/7/2025</a:t>
             </a:fld>
             <a:endParaRPr lang="en-US"/>
           </a:p>
@@ -468,7 +469,7 @@
           <a:p>
             <a:fld id="{D01D6C5B-8995-4CBE-A6C8-F37ABE6A0A7A}" type="datetimeFigureOut">
               <a:rPr lang="en-US" smtClean="0"/>
-              <a:t>3/6/2025</a:t>
+              <a:t>3/7/2025</a:t>
             </a:fld>
             <a:endParaRPr lang="en-US"/>
           </a:p>
@@ -683,7 +684,7 @@
           <a:p>
             <a:fld id="{D01D6C5B-8995-4CBE-A6C8-F37ABE6A0A7A}" type="datetimeFigureOut">
               <a:rPr lang="en-US" smtClean="0"/>
-              <a:t>3/6/2025</a:t>
+              <a:t>3/7/2025</a:t>
             </a:fld>
             <a:endParaRPr lang="en-US"/>
           </a:p>
@@ -884,7 +885,7 @@
           <a:p>
             <a:fld id="{D01D6C5B-8995-4CBE-A6C8-F37ABE6A0A7A}" type="datetimeFigureOut">
               <a:rPr lang="en-US" smtClean="0"/>
-              <a:t>3/6/2025</a:t>
+              <a:t>3/7/2025</a:t>
             </a:fld>
             <a:endParaRPr lang="en-US"/>
           </a:p>
@@ -1163,7 +1164,7 @@
           <a:p>
             <a:fld id="{D01D6C5B-8995-4CBE-A6C8-F37ABE6A0A7A}" type="datetimeFigureOut">
               <a:rPr lang="en-US" smtClean="0"/>
-              <a:t>3/6/2025</a:t>
+              <a:t>3/7/2025</a:t>
             </a:fld>
             <a:endParaRPr lang="en-US"/>
           </a:p>
@@ -1431,7 +1432,7 @@
           <a:p>
             <a:fld id="{D01D6C5B-8995-4CBE-A6C8-F37ABE6A0A7A}" type="datetimeFigureOut">
               <a:rPr lang="en-US" smtClean="0"/>
-              <a:t>3/6/2025</a:t>
+              <a:t>3/7/2025</a:t>
             </a:fld>
             <a:endParaRPr lang="en-US"/>
           </a:p>
@@ -1847,7 +1848,7 @@
           <a:p>
             <a:fld id="{D01D6C5B-8995-4CBE-A6C8-F37ABE6A0A7A}" type="datetimeFigureOut">
               <a:rPr lang="en-US" smtClean="0"/>
-              <a:t>3/6/2025</a:t>
+              <a:t>3/7/2025</a:t>
             </a:fld>
             <a:endParaRPr lang="en-US"/>
           </a:p>
@@ -1996,7 +1997,7 @@
           <a:p>
             <a:fld id="{D01D6C5B-8995-4CBE-A6C8-F37ABE6A0A7A}" type="datetimeFigureOut">
               <a:rPr lang="en-US" smtClean="0"/>
-              <a:t>3/6/2025</a:t>
+              <a:t>3/7/2025</a:t>
             </a:fld>
             <a:endParaRPr lang="en-US"/>
           </a:p>
@@ -2122,7 +2123,7 @@
           <a:p>
             <a:fld id="{D01D6C5B-8995-4CBE-A6C8-F37ABE6A0A7A}" type="datetimeFigureOut">
               <a:rPr lang="en-US" smtClean="0"/>
-              <a:t>3/6/2025</a:t>
+              <a:t>3/7/2025</a:t>
             </a:fld>
             <a:endParaRPr lang="en-US"/>
           </a:p>
@@ -2373,7 +2374,7 @@
           <a:p>
             <a:fld id="{D01D6C5B-8995-4CBE-A6C8-F37ABE6A0A7A}" type="datetimeFigureOut">
               <a:rPr lang="en-US" smtClean="0"/>
-              <a:t>3/6/2025</a:t>
+              <a:t>3/7/2025</a:t>
             </a:fld>
             <a:endParaRPr lang="en-US"/>
           </a:p>
@@ -2818,7 +2819,7 @@
           <a:p>
             <a:fld id="{D01D6C5B-8995-4CBE-A6C8-F37ABE6A0A7A}" type="datetimeFigureOut">
               <a:rPr lang="en-US" smtClean="0"/>
-              <a:t>3/6/2025</a:t>
+              <a:t>3/7/2025</a:t>
             </a:fld>
             <a:endParaRPr lang="en-US"/>
           </a:p>
@@ -3145,7 +3146,7 @@
           <a:p>
             <a:fld id="{D01D6C5B-8995-4CBE-A6C8-F37ABE6A0A7A}" type="datetimeFigureOut">
               <a:rPr lang="en-US" smtClean="0"/>
-              <a:t>3/6/2025</a:t>
+              <a:t>3/7/2025</a:t>
             </a:fld>
             <a:endParaRPr lang="en-US"/>
           </a:p>
@@ -3707,8 +3708,8 @@
         </p:nvSpPr>
         <p:spPr>
           <a:xfrm>
-            <a:off x="523664" y="4696300"/>
-            <a:ext cx="3788229" cy="1477328"/>
+            <a:off x="523664" y="4508825"/>
+            <a:ext cx="3788229" cy="1754326"/>
           </a:xfrm>
           <a:prstGeom prst="rect">
             <a:avLst/>
@@ -3752,10 +3753,19 @@
               <a:buChar char="•"/>
             </a:pPr>
             <a:r>
-              <a:rPr lang="en-US"/>
+              <a:rPr lang="en-US" dirty="0"/>
               <a:t>Mohamed Burhan</a:t>
             </a:r>
-            <a:endParaRPr lang="en-US" dirty="0"/>
+          </a:p>
+          <a:p>
+            <a:pPr marL="285750" indent="-285750">
+              <a:buFont typeface="Arial" panose="020B0604020202020204" pitchFamily="34" charset="0"/>
+              <a:buChar char="•"/>
+            </a:pPr>
+            <a:r>
+              <a:rPr lang="en-US" dirty="0"/>
+              <a:t>Gandhar Tare</a:t>
+            </a:r>
           </a:p>
           <a:p>
             <a:pPr marL="285750" indent="-285750">
@@ -4567,7 +4577,13 @@
   <p:cSld>
     <p:spTree>
       <p:nvGrpSpPr>
-        <p:cNvPr id="1" name=""/>
+        <p:cNvPr id="1" name="">
+          <a:extLst>
+            <a:ext uri="{FF2B5EF4-FFF2-40B4-BE49-F238E27FC236}">
+              <a16:creationId xmlns:a16="http://schemas.microsoft.com/office/drawing/2014/main" id="{A430DD48-EBB4-116D-5283-D88DC6D4DA2D}"/>
+            </a:ext>
+          </a:extLst>
+        </p:cNvPr>
         <p:cNvGrpSpPr/>
         <p:nvPr/>
       </p:nvGrpSpPr>
@@ -4584,7 +4600,7 @@
           <p:cNvPr id="2" name="Title 1">
             <a:extLst>
               <a:ext uri="{FF2B5EF4-FFF2-40B4-BE49-F238E27FC236}">
-                <a16:creationId xmlns:a16="http://schemas.microsoft.com/office/drawing/2014/main" id="{9A7DEDFD-A1CD-9A01-6420-5FC3C87F3EB0}"/>
+                <a16:creationId xmlns:a16="http://schemas.microsoft.com/office/drawing/2014/main" id="{A35FB580-3A23-DDB6-7404-3DF1B74E4DD3}"/>
               </a:ext>
             </a:extLst>
           </p:cNvPr>
@@ -4595,51 +4611,462 @@
             <p:ph type="title"/>
           </p:nvPr>
         </p:nvSpPr>
-        <p:spPr/>
-        <p:txBody>
-          <a:bodyPr/>
-          <a:lstStyle/>
-          <a:p>
-            <a:endParaRPr lang="en-US"/>
-          </a:p>
-        </p:txBody>
-      </p:sp>
-      <p:sp>
-        <p:nvSpPr>
-          <p:cNvPr id="3" name="Content Placeholder 2">
+        <p:spPr>
+          <a:xfrm>
+            <a:off x="838200" y="365126"/>
+            <a:ext cx="10515600" cy="527504"/>
+          </a:xfrm>
+        </p:spPr>
+        <p:txBody>
+          <a:bodyPr>
+            <a:noAutofit/>
+          </a:bodyPr>
+          <a:lstStyle/>
+          <a:p>
+            <a:pPr algn="ctr"/>
+            <a:r>
+              <a:rPr lang="en-US" dirty="0"/>
+              <a:t>Data Subset Overview &amp; Target Distribution</a:t>
+            </a:r>
+            <a:endParaRPr lang="en-US" sz="3200" dirty="0"/>
+          </a:p>
+        </p:txBody>
+      </p:sp>
+      <p:pic>
+        <p:nvPicPr>
+          <p:cNvPr id="8" name="Picture 7">
             <a:extLst>
               <a:ext uri="{FF2B5EF4-FFF2-40B4-BE49-F238E27FC236}">
-                <a16:creationId xmlns:a16="http://schemas.microsoft.com/office/drawing/2014/main" id="{2A71E191-BE0D-6D56-109C-DCE736DD458F}"/>
+                <a16:creationId xmlns:a16="http://schemas.microsoft.com/office/drawing/2014/main" id="{58FED12E-3F2B-5CC9-ACED-EC5CDFB03724}"/>
               </a:ext>
             </a:extLst>
           </p:cNvPr>
-          <p:cNvSpPr>
-            <a:spLocks noGrp="1"/>
-          </p:cNvSpPr>
-          <p:nvPr>
-            <p:ph idx="1"/>
-          </p:nvPr>
-        </p:nvSpPr>
-        <p:spPr/>
-        <p:txBody>
-          <a:bodyPr/>
-          <a:lstStyle/>
-          <a:p>
-            <a:r>
-              <a:rPr lang="en-US" dirty="0">
-                <a:highlight>
-                  <a:srgbClr val="FFFF00"/>
-                </a:highlight>
-              </a:rPr>
-              <a:t>THIS WITH MACHINE ANALYSIS NOW</a:t>
-            </a:r>
+          <p:cNvPicPr>
+            <a:picLocks noChangeAspect="1"/>
+          </p:cNvPicPr>
+          <p:nvPr/>
+        </p:nvPicPr>
+        <p:blipFill>
+          <a:blip r:embed="rId2"/>
+          <a:stretch>
+            <a:fillRect/>
+          </a:stretch>
+        </p:blipFill>
+        <p:spPr>
+          <a:xfrm>
+            <a:off x="201168" y="1481354"/>
+            <a:ext cx="6316561" cy="3943812"/>
+          </a:xfrm>
+          <a:prstGeom prst="rect">
+            <a:avLst/>
+          </a:prstGeom>
+        </p:spPr>
+      </p:pic>
+      <p:sp>
+        <p:nvSpPr>
+          <p:cNvPr id="14" name="TextBox 13">
+            <a:extLst>
+              <a:ext uri="{FF2B5EF4-FFF2-40B4-BE49-F238E27FC236}">
+                <a16:creationId xmlns:a16="http://schemas.microsoft.com/office/drawing/2014/main" id="{DEF2A708-E973-4194-2A1A-10645E416231}"/>
+              </a:ext>
+            </a:extLst>
+          </p:cNvPr>
+          <p:cNvSpPr txBox="1"/>
+          <p:nvPr/>
+        </p:nvSpPr>
+        <p:spPr>
+          <a:xfrm>
+            <a:off x="6517729" y="1536492"/>
+            <a:ext cx="4946754" cy="6309420"/>
+          </a:xfrm>
+          <a:prstGeom prst="rect">
+            <a:avLst/>
+          </a:prstGeom>
+          <a:noFill/>
+        </p:spPr>
+        <p:txBody>
+          <a:bodyPr wrap="square" rtlCol="0">
+            <a:spAutoFit/>
+          </a:bodyPr>
+          <a:lstStyle/>
+          <a:p>
+            <a:pPr marL="285750" indent="-285750">
+              <a:buFont typeface="Wingdings" panose="05000000000000000000" pitchFamily="2" charset="2"/>
+              <a:buChar char="§"/>
+            </a:pPr>
+            <a:r>
+              <a:rPr lang="en-US" b="1" dirty="0"/>
+              <a:t>What It Shows:</a:t>
+            </a:r>
+            <a:r>
+              <a:rPr lang="en-US" dirty="0"/>
+              <a:t> </a:t>
+            </a:r>
+          </a:p>
+          <a:p>
+            <a:pPr marL="285750" indent="-285750">
+              <a:buFont typeface="Wingdings" panose="05000000000000000000" pitchFamily="2" charset="2"/>
+              <a:buChar char="Ø"/>
+            </a:pPr>
+            <a:r>
+              <a:rPr lang="en-US" sz="1600" dirty="0"/>
+              <a:t>This bar chart presents the number of samples in each data subset from our 80/20 train/test split.</a:t>
+            </a:r>
+          </a:p>
+          <a:p>
+            <a:pPr marL="285750" indent="-285750">
+              <a:buFont typeface="Wingdings" panose="05000000000000000000" pitchFamily="2" charset="2"/>
+              <a:buChar char="Ø"/>
+            </a:pPr>
+            <a:r>
+              <a:rPr lang="en-US" sz="1600" dirty="0"/>
+              <a:t>It includes “Training Features (</a:t>
+            </a:r>
+            <a:r>
+              <a:rPr lang="en-US" sz="1600" dirty="0" err="1"/>
+              <a:t>x_train</a:t>
+            </a:r>
+            <a:r>
+              <a:rPr lang="en-US" sz="1600" dirty="0"/>
+              <a:t>)”, “Testing Features (</a:t>
+            </a:r>
+            <a:r>
+              <a:rPr lang="en-US" sz="1600" dirty="0" err="1"/>
+              <a:t>x_test</a:t>
+            </a:r>
+            <a:r>
+              <a:rPr lang="en-US" sz="1600" dirty="0"/>
+              <a:t>)”, “Training Labels (</a:t>
+            </a:r>
+            <a:r>
+              <a:rPr lang="en-US" sz="1600" dirty="0" err="1"/>
+              <a:t>y_train</a:t>
+            </a:r>
+            <a:r>
+              <a:rPr lang="en-US" sz="1600" dirty="0"/>
+              <a:t>)”, and “Testing Labels (</a:t>
+            </a:r>
+            <a:r>
+              <a:rPr lang="en-US" sz="1600" dirty="0" err="1"/>
+              <a:t>y_test</a:t>
+            </a:r>
+            <a:r>
+              <a:rPr lang="en-US" sz="1600" dirty="0"/>
+              <a:t>)”.</a:t>
+            </a:r>
+          </a:p>
+          <a:p>
+            <a:pPr marL="285750" indent="-285750">
+              <a:buFont typeface="Wingdings" panose="05000000000000000000" pitchFamily="2" charset="2"/>
+              <a:buChar char="§"/>
+            </a:pPr>
+            <a:r>
+              <a:rPr lang="en-US" b="1" dirty="0"/>
+              <a:t>Interpretation</a:t>
+            </a:r>
+            <a:r>
+              <a:rPr lang="en-US" dirty="0"/>
+              <a:t>:</a:t>
+            </a:r>
+          </a:p>
+          <a:p>
+            <a:pPr marL="285750" indent="-285750">
+              <a:buFont typeface="Wingdings" panose="05000000000000000000" pitchFamily="2" charset="2"/>
+              <a:buChar char="Ø"/>
+            </a:pPr>
+            <a:r>
+              <a:rPr lang="en-US" sz="1600" dirty="0"/>
+              <a:t>The chart confirms that approximately 80% of the samples are in the training set and 20% in the testing set. The exact counts, annotated on each bar, ensure we have a clear, balanced split.</a:t>
+            </a:r>
+          </a:p>
+          <a:p>
+            <a:pPr marL="285750" indent="-285750">
+              <a:buFont typeface="Wingdings" panose="05000000000000000000" pitchFamily="2" charset="2"/>
+              <a:buChar char="§"/>
+            </a:pPr>
+            <a:r>
+              <a:rPr lang="en-US" b="1" dirty="0"/>
+              <a:t>Machine Analysis Insight:</a:t>
+            </a:r>
+          </a:p>
+          <a:p>
+            <a:pPr marL="285750" indent="-285750">
+              <a:buFont typeface="Wingdings" panose="05000000000000000000" pitchFamily="2" charset="2"/>
+              <a:buChar char="Ø"/>
+            </a:pPr>
+            <a:r>
+              <a:rPr lang="en-US" sz="1600" dirty="0"/>
+              <a:t>Automated splitting methods were used to ensure that our data distribution remains consistent, which is crucial for building reliable predictive models.</a:t>
+            </a:r>
+          </a:p>
+          <a:p>
+            <a:pPr>
+              <a:buFont typeface="Arial" panose="020B0604020202020204" pitchFamily="34" charset="0"/>
+              <a:buChar char="•"/>
+            </a:pPr>
+            <a:endParaRPr lang="en-US" dirty="0"/>
+          </a:p>
+          <a:p>
+            <a:pPr>
+              <a:buFont typeface="Arial" panose="020B0604020202020204" pitchFamily="34" charset="0"/>
+              <a:buChar char="•"/>
+            </a:pPr>
+            <a:endParaRPr lang="en-US" dirty="0"/>
+          </a:p>
+          <a:p>
+            <a:pPr>
+              <a:buFont typeface="Arial" panose="020B0604020202020204" pitchFamily="34" charset="0"/>
+              <a:buChar char="•"/>
+            </a:pPr>
+            <a:endParaRPr lang="en-US" dirty="0"/>
+          </a:p>
+          <a:p>
+            <a:pPr>
+              <a:buFont typeface="Arial" panose="020B0604020202020204" pitchFamily="34" charset="0"/>
+              <a:buChar char="•"/>
+            </a:pPr>
+            <a:endParaRPr lang="en-US" dirty="0"/>
+          </a:p>
+          <a:p>
+            <a:pPr>
+              <a:buFont typeface="Arial" panose="020B0604020202020204" pitchFamily="34" charset="0"/>
+              <a:buChar char="•"/>
+            </a:pPr>
+            <a:endParaRPr lang="en-US" dirty="0"/>
+          </a:p>
+          <a:p>
+            <a:pPr>
+              <a:buFont typeface="Arial" panose="020B0604020202020204" pitchFamily="34" charset="0"/>
+              <a:buChar char="•"/>
+            </a:pPr>
+            <a:endParaRPr lang="en-US" dirty="0"/>
+          </a:p>
+          <a:p>
+            <a:pPr>
+              <a:buFont typeface="Arial" panose="020B0604020202020204" pitchFamily="34" charset="0"/>
+              <a:buChar char="•"/>
+            </a:pPr>
+            <a:endParaRPr lang="en-US" dirty="0"/>
+          </a:p>
+          <a:p>
+            <a:endParaRPr lang="en-US" dirty="0"/>
           </a:p>
         </p:txBody>
       </p:sp>
     </p:spTree>
     <p:extLst>
       <p:ext uri="{BB962C8B-B14F-4D97-AF65-F5344CB8AC3E}">
-        <p14:creationId xmlns:p14="http://schemas.microsoft.com/office/powerpoint/2010/main" val="3228748381"/>
+        <p14:creationId xmlns:p14="http://schemas.microsoft.com/office/powerpoint/2010/main" val="3955362193"/>
+      </p:ext>
+    </p:extLst>
+  </p:cSld>
+  <p:clrMapOvr>
+    <a:masterClrMapping/>
+  </p:clrMapOvr>
+</p:sld>
+</file>
+
+<file path=ppt/slides/slide8.xml><?xml version="1.0" encoding="utf-8"?>
+<p:sld xmlns:a="http://schemas.openxmlformats.org/drawingml/2006/main" xmlns:r="http://schemas.openxmlformats.org/officeDocument/2006/relationships" xmlns:p="http://schemas.openxmlformats.org/presentationml/2006/main">
+  <p:cSld>
+    <p:spTree>
+      <p:nvGrpSpPr>
+        <p:cNvPr id="1" name="">
+          <a:extLst>
+            <a:ext uri="{FF2B5EF4-FFF2-40B4-BE49-F238E27FC236}">
+              <a16:creationId xmlns:a16="http://schemas.microsoft.com/office/drawing/2014/main" id="{E41E387A-5694-D500-67AD-AB651B4E4A41}"/>
+            </a:ext>
+          </a:extLst>
+        </p:cNvPr>
+        <p:cNvGrpSpPr/>
+        <p:nvPr/>
+      </p:nvGrpSpPr>
+      <p:grpSpPr>
+        <a:xfrm>
+          <a:off x="0" y="0"/>
+          <a:ext cx="0" cy="0"/>
+          <a:chOff x="0" y="0"/>
+          <a:chExt cx="0" cy="0"/>
+        </a:xfrm>
+      </p:grpSpPr>
+      <p:sp>
+        <p:nvSpPr>
+          <p:cNvPr id="2" name="Title 1">
+            <a:extLst>
+              <a:ext uri="{FF2B5EF4-FFF2-40B4-BE49-F238E27FC236}">
+                <a16:creationId xmlns:a16="http://schemas.microsoft.com/office/drawing/2014/main" id="{32AA47F0-5FCA-34DB-E17B-63D480426D17}"/>
+              </a:ext>
+            </a:extLst>
+          </p:cNvPr>
+          <p:cNvSpPr>
+            <a:spLocks noGrp="1"/>
+          </p:cNvSpPr>
+          <p:nvPr>
+            <p:ph type="title"/>
+          </p:nvPr>
+        </p:nvSpPr>
+        <p:spPr>
+          <a:xfrm>
+            <a:off x="838200" y="365126"/>
+            <a:ext cx="10515600" cy="527504"/>
+          </a:xfrm>
+        </p:spPr>
+        <p:txBody>
+          <a:bodyPr>
+            <a:noAutofit/>
+          </a:bodyPr>
+          <a:lstStyle/>
+          <a:p>
+            <a:pPr algn="ctr"/>
+            <a:r>
+              <a:rPr lang="en-US" dirty="0"/>
+              <a:t>Distribution of Recovery Status</a:t>
+            </a:r>
+            <a:endParaRPr lang="en-US" sz="3200" dirty="0"/>
+          </a:p>
+        </p:txBody>
+      </p:sp>
+      <p:sp>
+        <p:nvSpPr>
+          <p:cNvPr id="6" name="TextBox 5">
+            <a:extLst>
+              <a:ext uri="{FF2B5EF4-FFF2-40B4-BE49-F238E27FC236}">
+                <a16:creationId xmlns:a16="http://schemas.microsoft.com/office/drawing/2014/main" id="{0C75D740-5FF8-9F91-E268-F855DCCD972A}"/>
+              </a:ext>
+            </a:extLst>
+          </p:cNvPr>
+          <p:cNvSpPr txBox="1"/>
+          <p:nvPr/>
+        </p:nvSpPr>
+        <p:spPr>
+          <a:xfrm>
+            <a:off x="6374259" y="1481354"/>
+            <a:ext cx="4572506" cy="3662541"/>
+          </a:xfrm>
+          <a:prstGeom prst="rect">
+            <a:avLst/>
+          </a:prstGeom>
+          <a:noFill/>
+        </p:spPr>
+        <p:txBody>
+          <a:bodyPr wrap="square" rtlCol="0">
+            <a:spAutoFit/>
+          </a:bodyPr>
+          <a:lstStyle/>
+          <a:p>
+            <a:pPr marL="285750" indent="-285750">
+              <a:spcAft>
+                <a:spcPts val="600"/>
+              </a:spcAft>
+              <a:buFont typeface="Wingdings" panose="05000000000000000000" pitchFamily="2" charset="2"/>
+              <a:buChar char="§"/>
+            </a:pPr>
+            <a:r>
+              <a:rPr lang="en-US" b="1" dirty="0"/>
+              <a:t>What It Shows:</a:t>
+            </a:r>
+          </a:p>
+          <a:p>
+            <a:pPr marL="285750" indent="-285750">
+              <a:spcAft>
+                <a:spcPts val="600"/>
+              </a:spcAft>
+              <a:buFont typeface="Wingdings" panose="05000000000000000000" pitchFamily="2" charset="2"/>
+              <a:buChar char="Ø"/>
+            </a:pPr>
+            <a:r>
+              <a:rPr lang="en-US" sz="1700" dirty="0"/>
+              <a:t>This count plot compares the number of recovered versus non-recovered patients across the training and testing sets.</a:t>
+            </a:r>
+          </a:p>
+          <a:p>
+            <a:pPr marL="285750" indent="-285750">
+              <a:spcAft>
+                <a:spcPts val="600"/>
+              </a:spcAft>
+              <a:buFont typeface="Wingdings" panose="05000000000000000000" pitchFamily="2" charset="2"/>
+              <a:buChar char="§"/>
+            </a:pPr>
+            <a:r>
+              <a:rPr lang="en-US" b="1" dirty="0"/>
+              <a:t>Interpretation:</a:t>
+            </a:r>
+          </a:p>
+          <a:p>
+            <a:pPr marL="285750" indent="-285750">
+              <a:spcAft>
+                <a:spcPts val="600"/>
+              </a:spcAft>
+              <a:buFont typeface="Wingdings" panose="05000000000000000000" pitchFamily="2" charset="2"/>
+              <a:buChar char="Ø"/>
+            </a:pPr>
+            <a:r>
+              <a:rPr lang="en-US" sz="1700" dirty="0"/>
+              <a:t>It verifies that the target variable distribution is maintained between the two subsets, preventing bias.</a:t>
+            </a:r>
+          </a:p>
+          <a:p>
+            <a:pPr marL="342900" indent="-342900">
+              <a:spcAft>
+                <a:spcPts val="600"/>
+              </a:spcAft>
+              <a:buFont typeface="Wingdings" panose="05000000000000000000" pitchFamily="2" charset="2"/>
+              <a:buChar char="§"/>
+            </a:pPr>
+            <a:r>
+              <a:rPr lang="en-US" b="1" dirty="0"/>
+              <a:t>Machine Analysis Insight:</a:t>
+            </a:r>
+          </a:p>
+          <a:p>
+            <a:pPr marL="342900" indent="-342900">
+              <a:spcAft>
+                <a:spcPts val="600"/>
+              </a:spcAft>
+              <a:buFont typeface="Wingdings" panose="05000000000000000000" pitchFamily="2" charset="2"/>
+              <a:buChar char="Ø"/>
+            </a:pPr>
+            <a:r>
+              <a:rPr lang="en-US" sz="1700" dirty="0"/>
+              <a:t>Preserving the inherent class balance through machine-driven preprocessing supports robust and unbiased model training.</a:t>
+            </a:r>
+          </a:p>
+        </p:txBody>
+      </p:sp>
+      <p:pic>
+        <p:nvPicPr>
+          <p:cNvPr id="5" name="Picture 4">
+            <a:extLst>
+              <a:ext uri="{FF2B5EF4-FFF2-40B4-BE49-F238E27FC236}">
+                <a16:creationId xmlns:a16="http://schemas.microsoft.com/office/drawing/2014/main" id="{875591ED-478D-CA9D-4E6E-45EBD5FBBA6B}"/>
+              </a:ext>
+            </a:extLst>
+          </p:cNvPr>
+          <p:cNvPicPr>
+            <a:picLocks noChangeAspect="1"/>
+          </p:cNvPicPr>
+          <p:nvPr/>
+        </p:nvPicPr>
+        <p:blipFill>
+          <a:blip r:embed="rId2"/>
+          <a:stretch>
+            <a:fillRect/>
+          </a:stretch>
+        </p:blipFill>
+        <p:spPr>
+          <a:xfrm>
+            <a:off x="253584" y="1481354"/>
+            <a:ext cx="6120675" cy="3984991"/>
+          </a:xfrm>
+          <a:prstGeom prst="rect">
+            <a:avLst/>
+          </a:prstGeom>
+        </p:spPr>
+      </p:pic>
+    </p:spTree>
+    <p:extLst>
+      <p:ext uri="{BB962C8B-B14F-4D97-AF65-F5344CB8AC3E}">
+        <p14:creationId xmlns:p14="http://schemas.microsoft.com/office/powerpoint/2010/main" val="4195371565"/>
       </p:ext>
     </p:extLst>
   </p:cSld>

</xml_diff>